<commit_message>
Quitar jerga de los titulares de la presentacion
"Un corpus que ya venia hecho para esto" no se entiende: "corpus" es jerga y la
frase no dice de que va la lamina. Pasa a "Por que este problema y no otro", que
responde directamente lo que pide el enunciado.

Tambien: la entradilla "Stack" pasa a "Con que esta hecho", el pie "Stack
tecnologico" a "Herramientas y despliegue", y "el corpus es documentacion
interna" a "los documentos son internos".

"Guardrails" se mantiene: es el termino tecnico del proyecto y el que se defiende
en la exposicion. Lo que se tradujo antes fue el CONTENIDO de la lamina 6 -- los
cuatro controles pasaron a ser preguntas en lenguaje llano -- no el titulo.

Co-Authored-By: Claude Opus 5 <noreply@anthropic.com>
</commit_message>
<xml_diff>
--- a/docs/NormIA.pptx
+++ b/docs/NormIA.pptx
@@ -9081,7 +9081,7 @@
                 </a:solidFill>
                 <a:latin typeface="Helvetica Neue"/>
               </a:rPr>
-              <a:t>Un corpus que ya venía hecho para esto</a:t>
+              <a:t>Por qué este problema y no otro</a:t>
             </a:r>
           </a:p>
         </p:txBody>
@@ -12886,7 +12886,7 @@
                 </a:solidFill>
                 <a:latin typeface="Helvetica Neue"/>
               </a:rPr>
-              <a:t>STACK TECNOLÓGICO</a:t>
+              <a:t>HERRAMIENTAS Y DESPLIEGUE</a:t>
             </a:r>
           </a:p>
         </p:txBody>
@@ -12964,7 +12964,7 @@
                 </a:solidFill>
                 <a:latin typeface="Helvetica Neue"/>
               </a:rPr>
-              <a:t>STACK</a:t>
+              <a:t>CON QUÉ ESTÁ HECHO</a:t>
             </a:r>
           </a:p>
         </p:txBody>
@@ -13314,7 +13314,7 @@
                 </a:solidFill>
                 <a:latin typeface="Helvetica Neue"/>
               </a:rPr>
-              <a:t> Cada paso —troceado, umbral, guardrails— es código legible y testeable; un framework habría escondido justo la parte que aporta el valor. 29 módulos, 177 tests.</a:t>
+              <a:t> Cada paso —troceado, umbral, guardrails— es código legible y comprobable; un framework habría escondido justo la parte que aporta el valor. 29 módulos, 177 tests.</a:t>
             </a:r>
           </a:p>
         </p:txBody>
@@ -14128,7 +14128,7 @@
                 </a:solidFill>
                 <a:latin typeface="Helvetica Neue"/>
               </a:rPr>
-              <a:t>Local, sin nube: el corpus es documentación interna. Clonar, instalar, configurar .env, ejecutar.</a:t>
+              <a:t>Local, sin nube: los documentos son internos. Clonar, instalar, configurar .env, ejecutar.</a:t>
             </a:r>
           </a:p>
         </p:txBody>

</xml_diff>

<commit_message>
Diagramas: paleta de la presentacion y etiquetas que no se recortan
Usaban el estilo por defecto de mermaid -- cajas lavanda, grupos amarillos --
que desentonaba con el resto. Ahora siguen la paleta del proyecto: los cuatro
guardrails en verde de sello, la escalacion en rojo, la respuesta valida en
verde, y el resto en blanco sobre gris.

El recorte de las etiquetas de grupo ("CLIENT[", "NUCLE(") costo cuatro intentos.
No era la fuente: con htmlLabels en true, mermaid mide el ancho del texto con
HTML y dibuja el rectangulo mas estrecho de lo que necesita. Forzar la fuente por
CSS lo empeoro, porque entonces medía con una y dibujaba con otra, y recortaba
hasta los nodos. La solucion es htmlLabels:false: con etiquetas SVG la medida es
correcta.

Se aplica tambien a los diagramas en linea del README.

Co-Authored-By: Claude Opus 5 <noreply@anthropic.com>
</commit_message>
<xml_diff>
--- a/docs/NormIA.pptx
+++ b/docs/NormIA.pptx
@@ -12166,8 +12166,8 @@
         </p:blipFill>
         <p:spPr>
           <a:xfrm>
-            <a:off x="3608242" y="1389888"/>
-            <a:ext cx="4975210" cy="4160520"/>
+            <a:off x="3261370" y="1389888"/>
+            <a:ext cx="5668954" cy="4160520"/>
           </a:xfrm>
           <a:prstGeom prst="rect">
             <a:avLst/>
@@ -12540,7 +12540,7 @@
         <p:spPr>
           <a:xfrm>
             <a:off x="566928" y="1728216"/>
-            <a:ext cx="11057839" cy="2347844"/>
+            <a:ext cx="11057839" cy="2438944"/>
           </a:xfrm>
           <a:prstGeom prst="roundRect">
             <a:avLst>
@@ -12596,7 +12596,7 @@
         <p:spPr>
           <a:xfrm>
             <a:off x="795528" y="1929384"/>
-            <a:ext cx="10600639" cy="1689476"/>
+            <a:ext cx="10600639" cy="1780576"/>
           </a:xfrm>
           <a:prstGeom prst="rect">
             <a:avLst/>
@@ -12611,7 +12611,7 @@
         </p:nvSpPr>
         <p:spPr>
           <a:xfrm>
-            <a:off x="822960" y="3728588"/>
+            <a:off x="822960" y="3819688"/>
             <a:ext cx="10545775" cy="310896"/>
           </a:xfrm>
           <a:prstGeom prst="rect">

</xml_diff>

<commit_message>
Corregir tres incoherencias de la lamina de herramientas
1. Decia "177 tests" y la lamina de resultados ya decia 195: el mismo mazo se
   contradecia. Son 195, y 30 modulos (no 29: se anadio app/security.py).

2. El modelo aparecia con dos nombres. La lamina de herramientas decia
   qwen3.8:27b-mlx y el diagrama de arquitectura Qwen3.5 27B, porque se cambio
   al rehacer los diagramas y no se unifico.

3. Y la etiqueta no describe el modelo. `ollama show` reporta arquitectura
   qwen3_5 y cuantizacion nvfp4: es Qwen3.5 27B en FP4, ni la version ni el
   formato que dice el nombre. Buscar "Qwen 3.8" no devuelve nada, y eso en una
   defensa es un riesgo gratuito.

La etiqueta literal se conserva donde es un comando o configuracion -- el pull de
ollama, el .env.example, el banco de pruebas -- porque es lo que Ollama resuelve
en local. Lo que cambia es como se DESCRIBE, con una nota junto al comando para
que no parezca una errata.

Co-Authored-By: Claude Opus 5 <noreply@anthropic.com>
</commit_message>
<xml_diff>
--- a/docs/NormIA.pptx
+++ b/docs/NormIA.pptx
@@ -4627,7 +4627,7 @@
                 </a:solidFill>
                 <a:latin typeface="Helvetica Neue"/>
               </a:rPr>
-              <a:t> Cada paso —troceado, umbral, guardrails— es código legible y comprobable; un framework habría escondido justo la parte que aporta el valor. 29 módulos, 177 tests.</a:t>
+              <a:t> Cada paso —troceado, umbral, guardrails— es código legible y comprobable; un framework habría escondido justo la parte que aporta el valor. 30 módulos, 195 tests.</a:t>
             </a:r>
           </a:p>
         </p:txBody>
@@ -4743,22 +4743,13 @@
               </a:lnSpc>
             </a:pPr>
             <a:r>
-              <a:rPr sz="950" b="0">
+              <a:rPr sz="1050" b="0">
                 <a:solidFill>
                   <a:srgbClr val="15191A"/>
                 </a:solidFill>
-                <a:latin typeface="Courier New"/>
-              </a:rPr>
-              <a:t>qwen3.8:27b-mlx</a:t>
-            </a:r>
-            <a:r>
-              <a:rPr sz="1050" b="0">
-                <a:solidFill>
-                  <a:srgbClr val="15191A"/>
-                </a:solidFill>
-                <a:latin typeface="Helvetica Neue"/>
-              </a:rPr>
-              <a:t> vía Ollama</a:t>
+                <a:latin typeface="Helvetica Neue"/>
+              </a:rPr>
+              <a:t>Qwen3.5 27B · FP4 · vía Ollama</a:t>
             </a:r>
           </a:p>
         </p:txBody>
@@ -15000,8 +14991,8 @@
         </p:blipFill>
         <p:spPr>
           <a:xfrm>
-            <a:off x="3261370" y="1389888"/>
-            <a:ext cx="5668954" cy="4160520"/>
+            <a:off x="3236722" y="1389888"/>
+            <a:ext cx="5718250" cy="4160520"/>
           </a:xfrm>
           <a:prstGeom prst="rect">
             <a:avLst/>

</xml_diff>